<commit_message>
Add offline verifiers, refresh the deck with real cases, drop committed logs
Verifiers: check_asmdef_refs.py compares each file's using directives against its asmdef references (catches CS0234/CS0012 before recompiling), check_scenes.py asserts components, camera, light and P3 asset wiring per scene, and console_errors.py filters errors out of the Unity console JSON. The two dotnet projects are now tracked: the Unity template's *.csproj rule ignored them because the exception sat before the rule it overrides.

The deck replaces abstractions with the actual cases: real event counts, the real command sequence and PA/hull numbers, real module ids, and a new slide with the four defects found while implementing. The exclusion list no longer claims there is no real art, which stopped being true.

Removes Assets/Logs, which had been committed by mistake: capture_game_view resolves save_path against the authoring root.
</commit_message>
<xml_diff>
--- a/docs/presentacion/TP2-VoidHex-Tactics.pptx
+++ b/docs/presentacion/TP2-VoidHex-Tactics.pptx
@@ -684,7 +684,13 @@
           <a:lstStyle/>
           <a:p>
             <a:r>
-              <a:t>50 s. Demo D4: agregar TractorBeamCommand en vivo. Valida PA, mueve la nave enemiga,</a:t>
+              <a:t>50 s. En la escena, ShieldCommand cuesta 2 PA y suma 4 de escudo: el pipeline no cambió.</a:t>
+            </a:r>
+          </a:p>
+          <a:p/>
+          <a:p>
+            <a:r>
+              <a:t>Demo D4: agregar TractorBeamCommand en vivo. Valida PA, mueve la nave enemiga,</a:t>
             </a:r>
           </a:p>
           <a:p>
@@ -915,18 +921,29 @@
           <a:lstStyle/>
           <a:p>
             <a:r>
-              <a:t>60 s. Columna izquierda demuestra DIP: si el catálogo viene de un servidor, el servicio no cambia.</a:t>
-            </a:r>
-          </a:p>
-          <a:p>
-            <a:r>
-              <a:t>Columna derecha demuestra data-driven: el diseñador agrega contenido sin tocar C#.</a:t>
+              <a:t>60 s. La escena equipa laser-mk1, lo reemplaza por laser-mk2, suma thruster-mk1 y shield-mk1.</a:t>
+            </a:r>
+          </a:p>
+          <a:p>
+            <a:r>
+              <a:t>Resultado real: PA 6, escudos 5, movimiento 4, habilidades [beam, barrier].</a:t>
             </a:r>
           </a:p>
           <a:p/>
           <a:p>
             <a:r>
-              <a:t>Demos: D5 (reemplazo MK I → MK II) y D6 (crear MK III como asset).</a:t>
+              <a:t>Columna izquierda demuestra DIP: si el catálogo viene de un servidor, el servicio no cambia.</a:t>
+            </a:r>
+          </a:p>
+          <a:p>
+            <a:r>
+              <a:t>Columna derecha demuestra data-driven: el MK III existe como asset, sin una clase nueva.</a:t>
+            </a:r>
+          </a:p>
+          <a:p/>
+          <a:p>
+            <a:r>
+              <a:t>Demos: D5 (reemplazo MK I → MK II) y D6 (equipar el MK III).</a:t>
             </a:r>
           </a:p>
         </p:txBody>
@@ -996,12 +1013,24 @@
           <a:lstStyle/>
           <a:p>
             <a:r>
-              <a:t>50 s. ANTES DE PRESENTAR: reemplazar los números por los reales del Test Runner</a:t>
-            </a:r>
-          </a:p>
-          <a:p>
-            <a:r>
-              <a:t>y adjuntar la captura. No decir un número que no se pueda respaldar.</a:t>
+              <a:t>50 s. 21 en Edit Mode y 1 en Play Mode: 22, corridos y verdes dos veces (antes y después</a:t>
+            </a:r>
+          </a:p>
+          <a:p>
+            <a:r>
+              <a:t> del rediseño de UI y de los assets).</a:t>
+            </a:r>
+          </a:p>
+          <a:p/>
+          <a:p>
+            <a:r>
+              <a:t>El único Play Mode es P2 porque es el único donde importa que Unity invoque al adaptador.</a:t>
+            </a:r>
+          </a:p>
+          <a:p/>
+          <a:p>
+            <a:r>
+              <a:t>Si preguntan qué detectaría cada uno, la matriz de docs/04 tiene la columna completa.</a:t>
             </a:r>
           </a:p>
         </p:txBody>
@@ -1079,6 +1108,17 @@
               <a:t>Cada fila tiene por dónde crecer.</a:t>
             </a:r>
           </a:p>
+          <a:p/>
+          <a:p>
+            <a:r>
+              <a:t>Ojo: sí hay arte 3D real (modelos del Kenney Space Kit). Lo excluido es la animación</a:t>
+            </a:r>
+          </a:p>
+          <a:p>
+            <a:r>
+              <a:t>con clips; el movimiento es por transform.</a:t>
+            </a:r>
+          </a:p>
         </p:txBody>
       </p:sp>
       <p:sp>
@@ -1146,7 +1186,45 @@
           <a:lstStyle/>
           <a:p>
             <a:r>
-              <a:t>35 s. Todos están documentados en docs/01-arquitectura.md §5.</a:t>
+              <a:t>45 s. Esto responde "qué descubriste al implementar", que la consigna pide explícitamente (§4.1).</a:t>
+            </a:r>
+          </a:p>
+          <a:p/>
+          <a:p>
+            <a:r>
+              <a:t>El más útil para contar: el del pivote. Perdí tiempo buscando en la arquitectura algo que</a:t>
+            </a:r>
+          </a:p>
+          <a:p>
+            <a:r>
+              <a:t>era un problema de importación de assets. Enseña a agotar la hipótesis barata antes.</a:t>
+            </a:r>
+          </a:p>
+          <a:p/>
+          <a:p>
+            <a:r>
+              <a:t>El segundo es el más arquitectónico: una vista que busca referencias por nombre de ruta</a:t>
+            </a:r>
+          </a:p>
+          <a:p>
+            <a:r>
+              <a:t>no es una vista, es una dependencia oculta. Ahora la fábrica de UI devuelve tipos.</a:t>
+            </a:r>
+          </a:p>
+          <a:p/>
+          <a:p>
+            <a:r>
+              <a:t>Un quinto caso, si preguntan por los tests: una aserción mía estaba mal escrita</a:t>
+            </a:r>
+          </a:p>
+          <a:p>
+            <a:r>
+              <a:t>(la ruta costaba 3, no 4). Lo detecté corriendo la lógica fuera del editor.</a:t>
+            </a:r>
+          </a:p>
+          <a:p>
+            <a:r>
+              <a:t>Los tests también pueden estar equivocados; por eso el auditor existe.</a:t>
             </a:r>
           </a:p>
         </p:txBody>
@@ -1522,7 +1600,23 @@
           <a:lstStyle/>
           <a:p>
             <a:r>
-              <a:t>Código de salida 0 = suite verde.</a:t>
+              <a:t>El CLI (com.unity.pipeline) permite recompilar, ejecutar menús, correr tests y capturar</a:t>
+            </a:r>
+          </a:p>
+          <a:p>
+            <a:r>
+              <a:t>el game view con el editor abierto. Es lo que se usó para verificar cada cambio de esta entrega.</a:t>
+            </a:r>
+          </a:p>
+          <a:p/>
+          <a:p>
+            <a:r>
+              <a:t>Si preguntan por batchmode: también existe, pero requiere el proyecto sin lock, es decir</a:t>
+            </a:r>
+          </a:p>
+          <a:p>
+            <a:r>
+              <a:t>el editor cerrado. El CLI no.</a:t>
             </a:r>
           </a:p>
         </p:txBody>
@@ -1829,23 +1923,33 @@
           <a:lstStyle/>
           <a:p>
             <a:r>
-              <a:t>60 s. Usan reflexión: verifican que el contrato de publicación solo tenga eventos</a:t>
-            </a:r>
-          </a:p>
-          <a:p>
-            <a:r>
-              <a:t>y que el de lectura no tenga mutaciones.</a:t>
+              <a:t>60 s. Escena real: mapa 12×12 con asteroides y cristales del Kenney Space Kit.</a:t>
+            </a:r>
+          </a:p>
+          <a:p>
+            <a:r>
+              <a:t>La ruta al destino es de 21 celdas y costo 20; el contador de eventos queda en 4,</a:t>
+            </a:r>
+          </a:p>
+          <a:p>
+            <a:r>
+              <a:t>que es exactamente la cantidad de obstáculos colocados.</a:t>
             </a:r>
           </a:p>
           <a:p/>
           <a:p>
             <a:r>
-              <a:t>Si mañana alguien agrega SetCell a la interfaz de lectura, el test se pone rojo</a:t>
-            </a:r>
-          </a:p>
-          <a:p>
-            <a:r>
-              <a:t>antes de que llegue a la UI.</a:t>
+              <a:t>Los dos primeros tests usan reflexión: verifican que el contrato de publicación solo</a:t>
+            </a:r>
+          </a:p>
+          <a:p>
+            <a:r>
+              <a:t>tenga eventos y que el de lectura no tenga mutaciones. Si mañana alguien agrega SetCell</a:t>
+            </a:r>
+          </a:p>
+          <a:p>
+            <a:r>
+              <a:t>a la interfaz de lectura, el test se pone rojo antes de que llegue a la UI.</a:t>
             </a:r>
           </a:p>
         </p:txBody>
@@ -5368,7 +5472,7 @@
                 </a:solidFill>
                 <a:latin typeface="Segoe UI"/>
               </a:rPr>
-              <a:t>ISP + Observer</a:t>
+              <a:t>ISP + Observer · 5 tests</a:t>
             </a:r>
           </a:p>
         </p:txBody>
@@ -5492,7 +5596,7 @@
                 </a:solidFill>
                 <a:latin typeface="Segoe UI"/>
               </a:rPr>
-              <a:t>Pipeline async</a:t>
+              <a:t>Pipeline async · 8 tests</a:t>
             </a:r>
           </a:p>
         </p:txBody>
@@ -5616,7 +5720,7 @@
                 </a:solidFill>
                 <a:latin typeface="Segoe UI"/>
               </a:rPr>
-              <a:t>DI + Data-driven</a:t>
+              <a:t>DI + Data-driven · 9 tests</a:t>
             </a:r>
           </a:p>
         </p:txBody>
@@ -5655,7 +5759,7 @@
                 </a:solidFill>
                 <a:latin typeface="Segoe UI"/>
               </a:rPr>
-              <a:t>Matias Andres Fahler   ·   Unity 6000.5.9f1   ·   tag tp2</a:t>
+              <a:t>Matias Andres Fahler   ·   Unity 6000.5.9f1   ·   tag tp2   ·   22 tests verdes</a:t>
             </a:r>
           </a:p>
         </p:txBody>
@@ -6414,6 +6518,169 @@
         </p:nvSpPr>
         <p:spPr>
           <a:xfrm>
+            <a:off x="6492240" y="3886200"/>
+            <a:ext cx="5120640" cy="1481328"/>
+          </a:xfrm>
+          <a:prstGeom prst="roundRect">
+            <a:avLst>
+              <a:gd name="adj" fmla="val 6000"/>
+            </a:avLst>
+          </a:prstGeom>
+          <a:solidFill>
+            <a:srgbClr val="24334A"/>
+          </a:solidFill>
+          <a:ln w="13970">
+            <a:solidFill>
+              <a:srgbClr val="334155"/>
+            </a:solidFill>
+          </a:ln>
+          <a:effectLst/>
+        </p:spPr>
+        <p:style>
+          <a:lnRef idx="1">
+            <a:schemeClr val="accent1"/>
+          </a:lnRef>
+          <a:fillRef idx="3">
+            <a:schemeClr val="accent1"/>
+          </a:fillRef>
+          <a:effectRef idx="2">
+            <a:schemeClr val="accent1"/>
+          </a:effectRef>
+          <a:fontRef idx="minor">
+            <a:schemeClr val="lt1"/>
+          </a:fontRef>
+        </p:style>
+        <p:txBody>
+          <a:bodyPr rtlCol="0" anchor="ctr"/>
+          <a:lstStyle/>
+          <a:p/>
+        </p:txBody>
+      </p:sp>
+      <p:sp>
+        <p:nvSpPr>
+          <p:cNvPr id="21" name="TextBox 20"/>
+          <p:cNvSpPr txBox="1"/>
+          <p:nvPr/>
+        </p:nvSpPr>
+        <p:spPr>
+          <a:xfrm>
+            <a:off x="6693408" y="4005072"/>
+            <a:ext cx="4754880" cy="256032"/>
+          </a:xfrm>
+          <a:prstGeom prst="rect">
+            <a:avLst/>
+          </a:prstGeom>
+          <a:noFill/>
+        </p:spPr>
+        <p:txBody>
+          <a:bodyPr wrap="square" anchor="t" lIns="0" rIns="0" tIns="0" bIns="0">
+            <a:spAutoFit/>
+          </a:bodyPr>
+          <a:lstStyle/>
+          <a:p>
+            <a:pPr algn="l">
+              <a:lnSpc>
+                <a:spcPct val="100000"/>
+              </a:lnSpc>
+            </a:pPr>
+            <a:r>
+              <a:rPr sz="1050" b="1" i="0">
+                <a:solidFill>
+                  <a:srgbClr val="A78BFA"/>
+                </a:solidFill>
+                <a:latin typeface="Segoe UI"/>
+              </a:rPr>
+              <a:t>CORRIDA REAL DE LA ESCENA</a:t>
+            </a:r>
+          </a:p>
+        </p:txBody>
+      </p:sp>
+      <p:sp>
+        <p:nvSpPr>
+          <p:cNvPr id="22" name="TextBox 21"/>
+          <p:cNvSpPr txBox="1"/>
+          <p:nvPr/>
+        </p:nvSpPr>
+        <p:spPr>
+          <a:xfrm>
+            <a:off x="6693408" y="4279392"/>
+            <a:ext cx="4754880" cy="822960"/>
+          </a:xfrm>
+          <a:prstGeom prst="rect">
+            <a:avLst/>
+          </a:prstGeom>
+          <a:noFill/>
+        </p:spPr>
+        <p:txBody>
+          <a:bodyPr wrap="square" anchor="t" lIns="0" rIns="0" tIns="0" bIns="0">
+            <a:spAutoFit/>
+          </a:bodyPr>
+          <a:lstStyle/>
+          <a:p>
+            <a:pPr algn="l">
+              <a:lnSpc>
+                <a:spcPct val="100000"/>
+              </a:lnSpc>
+            </a:pPr>
+            <a:r>
+              <a:rPr sz="1100" b="0" i="0">
+                <a:solidFill>
+                  <a:srgbClr val="CBD5E1"/>
+                </a:solidFill>
+                <a:latin typeface="Consolas"/>
+              </a:rPr>
+              <a:t>Mover (2,0) 2 PA → Atacar 2 PA → Mover (3,0) 1 PA</a:t>
+            </a:r>
+          </a:p>
+        </p:txBody>
+      </p:sp>
+      <p:sp>
+        <p:nvSpPr>
+          <p:cNvPr id="23" name="TextBox 22"/>
+          <p:cNvSpPr txBox="1"/>
+          <p:nvPr/>
+        </p:nvSpPr>
+        <p:spPr>
+          <a:xfrm>
+            <a:off x="6693408" y="4590288"/>
+            <a:ext cx="4754880" cy="274320"/>
+          </a:xfrm>
+          <a:prstGeom prst="rect">
+            <a:avLst/>
+          </a:prstGeom>
+          <a:noFill/>
+        </p:spPr>
+        <p:txBody>
+          <a:bodyPr wrap="square" anchor="t" lIns="0" rIns="0" tIns="0" bIns="0">
+            <a:spAutoFit/>
+          </a:bodyPr>
+          <a:lstStyle/>
+          <a:p>
+            <a:pPr algn="l">
+              <a:lnSpc>
+                <a:spcPct val="100000"/>
+              </a:lnSpc>
+            </a:pPr>
+            <a:r>
+              <a:rPr sz="1100" b="1" i="0">
+                <a:solidFill>
+                  <a:srgbClr val="4ADE80"/>
+                </a:solidFill>
+                <a:latin typeface="Segoe UI"/>
+              </a:rPr>
+              <a:t>PA 6 → 1   ·   hull enemigo 6 → 3</a:t>
+            </a:r>
+          </a:p>
+        </p:txBody>
+      </p:sp>
+      <p:sp>
+        <p:nvSpPr>
+          <p:cNvPr id="24" name="Rounded Rectangle 23"/>
+          <p:cNvSpPr/>
+          <p:nvPr/>
+        </p:nvSpPr>
+        <p:spPr>
+          <a:xfrm>
             <a:off x="566928" y="5925312"/>
             <a:ext cx="11057839" cy="475488"/>
           </a:xfrm>
@@ -6452,7 +6719,7 @@
       </p:sp>
       <p:sp>
         <p:nvSpPr>
-          <p:cNvPr id="21" name="Rounded Rectangle 20"/>
+          <p:cNvPr id="25" name="Rounded Rectangle 24"/>
           <p:cNvSpPr/>
           <p:nvPr/>
         </p:nvSpPr>
@@ -6496,7 +6763,7 @@
       </p:sp>
       <p:sp>
         <p:nvSpPr>
-          <p:cNvPr id="22" name="TextBox 21"/>
+          <p:cNvPr id="26" name="TextBox 25"/>
           <p:cNvSpPr txBox="1"/>
           <p:nvPr/>
         </p:nvSpPr>
@@ -9896,7 +10163,7 @@
                 </a:solidFill>
                 <a:latin typeface="Segoe UI"/>
               </a:rPr>
-              <a:t>DIP: mock inyectado</a:t>
+              <a:t>DIP: catálogo inyectado</a:t>
             </a:r>
           </a:p>
         </p:txBody>
@@ -9957,7 +10224,7 @@
                 </a:solidFill>
                 <a:latin typeface="Segoe UI"/>
               </a:rPr>
-              <a:t>·  El fake cuenta las consultas</a:t>
+              <a:t>·  El test inyecta FakeCatalog y cuenta consultas</a:t>
             </a:r>
           </a:p>
           <a:p>
@@ -10103,7 +10370,7 @@
                 </a:solidFill>
                 <a:latin typeface="Segoe UI"/>
               </a:rPr>
-              <a:t>·  Crear un ShipModuleAsset MK III en el inspector</a:t>
+              <a:t>·  laser-mk1 → laser-mk2 reemplaza en el slot</a:t>
             </a:r>
           </a:p>
           <a:p>
@@ -10122,7 +10389,7 @@
                 </a:solidFill>
                 <a:latin typeface="Segoe UI"/>
               </a:rPr>
-              <a:t>·  Se equipa y recalcula stats</a:t>
+              <a:t>·  laser-mk3 se agregó como asset, no como clase</a:t>
             </a:r>
           </a:p>
           <a:p>
@@ -10141,7 +10408,7 @@
                 </a:solidFill>
                 <a:latin typeface="Segoe UI"/>
               </a:rPr>
-              <a:t>·  No se recompila nada</a:t>
+              <a:t>·  Stats: PA 6 · escudos 5 · movimiento 4</a:t>
             </a:r>
           </a:p>
         </p:txBody>
@@ -12830,7 +13097,7 @@
                 </a:solidFill>
                 <a:latin typeface="Segoe UI"/>
               </a:rPr>
-              <a:t>Arte y animaciones reales</a:t>
+              <a:t>Animación con clips</a:t>
             </a:r>
           </a:p>
         </p:txBody>
@@ -12915,7 +13182,7 @@
                 </a:solidFill>
                 <a:latin typeface="Segoe UI"/>
               </a:rPr>
-              <a:t>No demuestran la propiedad y acoplan tiempos</a:t>
+              <a:t>Los modelos se mueven por transform, sin Animator</a:t>
             </a:r>
           </a:p>
         </p:txBody>
@@ -13000,7 +13267,7 @@
                 </a:solidFill>
                 <a:latin typeface="Segoe UI"/>
               </a:rPr>
-              <a:t>ShipView es el punto de sustitución</a:t>
+              <a:t>Animator sobre el modelo actual</a:t>
             </a:r>
           </a:p>
         </p:txBody>
@@ -13737,7 +14004,7 @@
                 </a:solidFill>
                 <a:latin typeface="Segoe UI"/>
               </a:rPr>
-              <a:t>AJUSTES</a:t>
+              <a:t>AJUSTES Y HALLAZGOS</a:t>
             </a:r>
           </a:p>
         </p:txBody>
@@ -13776,7 +14043,7 @@
                 </a:solidFill>
                 <a:latin typeface="Segoe UI"/>
               </a:rPr>
-              <a:t>Qué cambié respecto del TP1</a:t>
+              <a:t>Qué cambié, y qué descubrí al implementar</a:t>
             </a:r>
           </a:p>
         </p:txBody>
@@ -13835,8 +14102,8 @@
         </p:nvSpPr>
         <p:spPr>
           <a:xfrm>
-            <a:off x="566928" y="1783080"/>
-            <a:ext cx="3642582" cy="713232"/>
+            <a:off x="566928" y="1691640"/>
+            <a:ext cx="3642582" cy="512064"/>
           </a:xfrm>
           <a:prstGeom prst="rect">
             <a:avLst/>
@@ -13881,8 +14148,8 @@
         </p:nvSpPr>
         <p:spPr>
           <a:xfrm>
-            <a:off x="694944" y="1837943"/>
-            <a:ext cx="3386550" cy="603504"/>
+            <a:off x="694944" y="1746504"/>
+            <a:ext cx="3386550" cy="402336"/>
           </a:xfrm>
           <a:prstGeom prst="rect">
             <a:avLst/>
@@ -13920,8 +14187,8 @@
         </p:nvSpPr>
         <p:spPr>
           <a:xfrm>
-            <a:off x="4209510" y="1783080"/>
-            <a:ext cx="4032859" cy="713232"/>
+            <a:off x="4209510" y="1691640"/>
+            <a:ext cx="4032859" cy="512064"/>
           </a:xfrm>
           <a:prstGeom prst="rect">
             <a:avLst/>
@@ -13966,8 +14233,8 @@
         </p:nvSpPr>
         <p:spPr>
           <a:xfrm>
-            <a:off x="4337526" y="1837943"/>
-            <a:ext cx="3776827" cy="603504"/>
+            <a:off x="4337526" y="1746504"/>
+            <a:ext cx="3776827" cy="402336"/>
           </a:xfrm>
           <a:prstGeom prst="rect">
             <a:avLst/>
@@ -14005,8 +14272,8 @@
         </p:nvSpPr>
         <p:spPr>
           <a:xfrm>
-            <a:off x="8242369" y="1783080"/>
-            <a:ext cx="3382397" cy="713232"/>
+            <a:off x="8242369" y="1691640"/>
+            <a:ext cx="3382397" cy="512064"/>
           </a:xfrm>
           <a:prstGeom prst="rect">
             <a:avLst/>
@@ -14051,8 +14318,8 @@
         </p:nvSpPr>
         <p:spPr>
           <a:xfrm>
-            <a:off x="8370385" y="1837943"/>
-            <a:ext cx="3126365" cy="603504"/>
+            <a:off x="8370385" y="1746504"/>
+            <a:ext cx="3126365" cy="402336"/>
           </a:xfrm>
           <a:prstGeom prst="rect">
             <a:avLst/>
@@ -14090,8 +14357,8 @@
         </p:nvSpPr>
         <p:spPr>
           <a:xfrm>
-            <a:off x="566928" y="2496312"/>
-            <a:ext cx="3642582" cy="713232"/>
+            <a:off x="566928" y="2203704"/>
+            <a:ext cx="3642582" cy="512064"/>
           </a:xfrm>
           <a:prstGeom prst="rect">
             <a:avLst/>
@@ -14136,8 +14403,8 @@
         </p:nvSpPr>
         <p:spPr>
           <a:xfrm>
-            <a:off x="694944" y="2551176"/>
-            <a:ext cx="3386550" cy="603504"/>
+            <a:off x="694944" y="2258568"/>
+            <a:ext cx="3386550" cy="402336"/>
           </a:xfrm>
           <a:prstGeom prst="rect">
             <a:avLst/>
@@ -14156,7 +14423,7 @@
               </a:lnSpc>
             </a:pPr>
             <a:r>
-              <a:rPr sz="1200" b="0" i="0">
+              <a:rPr sz="1150" b="0" i="0">
                 <a:solidFill>
                   <a:srgbClr val="CBD5E1"/>
                 </a:solidFill>
@@ -14175,8 +14442,8 @@
         </p:nvSpPr>
         <p:spPr>
           <a:xfrm>
-            <a:off x="4209510" y="2496312"/>
-            <a:ext cx="4032859" cy="713232"/>
+            <a:off x="4209510" y="2203704"/>
+            <a:ext cx="4032859" cy="512064"/>
           </a:xfrm>
           <a:prstGeom prst="rect">
             <a:avLst/>
@@ -14221,8 +14488,8 @@
         </p:nvSpPr>
         <p:spPr>
           <a:xfrm>
-            <a:off x="4337526" y="2551176"/>
-            <a:ext cx="3776827" cy="603504"/>
+            <a:off x="4337526" y="2258568"/>
+            <a:ext cx="3776827" cy="402336"/>
           </a:xfrm>
           <a:prstGeom prst="rect">
             <a:avLst/>
@@ -14241,7 +14508,7 @@
               </a:lnSpc>
             </a:pPr>
             <a:r>
-              <a:rPr sz="1200" b="0" i="0">
+              <a:rPr sz="1150" b="0" i="0">
                 <a:solidFill>
                   <a:srgbClr val="CBD5E1"/>
                 </a:solidFill>
@@ -14260,8 +14527,8 @@
         </p:nvSpPr>
         <p:spPr>
           <a:xfrm>
-            <a:off x="8242369" y="2496312"/>
-            <a:ext cx="3382397" cy="713232"/>
+            <a:off x="8242369" y="2203704"/>
+            <a:ext cx="3382397" cy="512064"/>
           </a:xfrm>
           <a:prstGeom prst="rect">
             <a:avLst/>
@@ -14306,8 +14573,8 @@
         </p:nvSpPr>
         <p:spPr>
           <a:xfrm>
-            <a:off x="8370385" y="2551176"/>
-            <a:ext cx="3126365" cy="603504"/>
+            <a:off x="8370385" y="2258568"/>
+            <a:ext cx="3126365" cy="402336"/>
           </a:xfrm>
           <a:prstGeom prst="rect">
             <a:avLst/>
@@ -14326,7 +14593,7 @@
               </a:lnSpc>
             </a:pPr>
             <a:r>
-              <a:rPr sz="1200" b="0" i="0">
+              <a:rPr sz="1150" b="0" i="0">
                 <a:solidFill>
                   <a:srgbClr val="CBD5E1"/>
                 </a:solidFill>
@@ -14345,8 +14612,8 @@
         </p:nvSpPr>
         <p:spPr>
           <a:xfrm>
-            <a:off x="566928" y="3209544"/>
-            <a:ext cx="3642582" cy="713232"/>
+            <a:off x="566928" y="2715768"/>
+            <a:ext cx="3642582" cy="512064"/>
           </a:xfrm>
           <a:prstGeom prst="rect">
             <a:avLst/>
@@ -14391,8 +14658,8 @@
         </p:nvSpPr>
         <p:spPr>
           <a:xfrm>
-            <a:off x="694944" y="3264408"/>
-            <a:ext cx="3386550" cy="603504"/>
+            <a:off x="694944" y="2770632"/>
+            <a:ext cx="3386550" cy="402336"/>
           </a:xfrm>
           <a:prstGeom prst="rect">
             <a:avLst/>
@@ -14411,7 +14678,7 @@
               </a:lnSpc>
             </a:pPr>
             <a:r>
-              <a:rPr sz="1200" b="0" i="0">
+              <a:rPr sz="1150" b="0" i="0">
                 <a:solidFill>
                   <a:srgbClr val="CBD5E1"/>
                 </a:solidFill>
@@ -14430,8 +14697,8 @@
         </p:nvSpPr>
         <p:spPr>
           <a:xfrm>
-            <a:off x="4209510" y="3209544"/>
-            <a:ext cx="4032859" cy="713232"/>
+            <a:off x="4209510" y="2715768"/>
+            <a:ext cx="4032859" cy="512064"/>
           </a:xfrm>
           <a:prstGeom prst="rect">
             <a:avLst/>
@@ -14476,8 +14743,8 @@
         </p:nvSpPr>
         <p:spPr>
           <a:xfrm>
-            <a:off x="4337526" y="3264408"/>
-            <a:ext cx="3776827" cy="603504"/>
+            <a:off x="4337526" y="2770632"/>
+            <a:ext cx="3776827" cy="402336"/>
           </a:xfrm>
           <a:prstGeom prst="rect">
             <a:avLst/>
@@ -14496,7 +14763,7 @@
               </a:lnSpc>
             </a:pPr>
             <a:r>
-              <a:rPr sz="1200" b="0" i="0">
+              <a:rPr sz="1150" b="0" i="0">
                 <a:solidFill>
                   <a:srgbClr val="CBD5E1"/>
                 </a:solidFill>
@@ -14515,8 +14782,8 @@
         </p:nvSpPr>
         <p:spPr>
           <a:xfrm>
-            <a:off x="8242369" y="3209544"/>
-            <a:ext cx="3382397" cy="713232"/>
+            <a:off x="8242369" y="2715768"/>
+            <a:ext cx="3382397" cy="512064"/>
           </a:xfrm>
           <a:prstGeom prst="rect">
             <a:avLst/>
@@ -14561,8 +14828,8 @@
         </p:nvSpPr>
         <p:spPr>
           <a:xfrm>
-            <a:off x="8370385" y="3264408"/>
-            <a:ext cx="3126365" cy="603504"/>
+            <a:off x="8370385" y="2770632"/>
+            <a:ext cx="3126365" cy="402336"/>
           </a:xfrm>
           <a:prstGeom prst="rect">
             <a:avLst/>
@@ -14581,7 +14848,7 @@
               </a:lnSpc>
             </a:pPr>
             <a:r>
-              <a:rPr sz="1200" b="0" i="0">
+              <a:rPr sz="1150" b="0" i="0">
                 <a:solidFill>
                   <a:srgbClr val="CBD5E1"/>
                 </a:solidFill>
@@ -14600,8 +14867,8 @@
         </p:nvSpPr>
         <p:spPr>
           <a:xfrm>
-            <a:off x="566928" y="3922776"/>
-            <a:ext cx="3642582" cy="713232"/>
+            <a:off x="566928" y="3227832"/>
+            <a:ext cx="3642582" cy="512064"/>
           </a:xfrm>
           <a:prstGeom prst="rect">
             <a:avLst/>
@@ -14646,8 +14913,8 @@
         </p:nvSpPr>
         <p:spPr>
           <a:xfrm>
-            <a:off x="694944" y="3977639"/>
-            <a:ext cx="3386550" cy="603504"/>
+            <a:off x="694944" y="3282696"/>
+            <a:ext cx="3386550" cy="402336"/>
           </a:xfrm>
           <a:prstGeom prst="rect">
             <a:avLst/>
@@ -14666,13 +14933,13 @@
               </a:lnSpc>
             </a:pPr>
             <a:r>
-              <a:rPr sz="1200" b="0" i="0">
+              <a:rPr sz="1150" b="0" i="0">
                 <a:solidFill>
                   <a:srgbClr val="CBD5E1"/>
                 </a:solidFill>
                 <a:latin typeface="Segoe UI"/>
               </a:rPr>
-              <a:t>Slots validan el tipo</a:t>
+              <a:t>FSM con estados por acción</a:t>
             </a:r>
           </a:p>
         </p:txBody>
@@ -14685,8 +14952,8 @@
         </p:nvSpPr>
         <p:spPr>
           <a:xfrm>
-            <a:off x="4209510" y="3922776"/>
-            <a:ext cx="4032859" cy="713232"/>
+            <a:off x="4209510" y="3227832"/>
+            <a:ext cx="4032859" cy="512064"/>
           </a:xfrm>
           <a:prstGeom prst="rect">
             <a:avLst/>
@@ -14731,8 +14998,8 @@
         </p:nvSpPr>
         <p:spPr>
           <a:xfrm>
-            <a:off x="4337526" y="3977639"/>
-            <a:ext cx="3776827" cy="603504"/>
+            <a:off x="4337526" y="3282696"/>
+            <a:ext cx="3776827" cy="402336"/>
           </a:xfrm>
           <a:prstGeom prst="rect">
             <a:avLst/>
@@ -14751,13 +15018,13 @@
               </a:lnSpc>
             </a:pPr>
             <a:r>
-              <a:rPr sz="1200" b="0" i="0">
+              <a:rPr sz="1150" b="0" i="0">
                 <a:solidFill>
                   <a:srgbClr val="CBD5E1"/>
                 </a:solidFill>
                 <a:latin typeface="Segoe UI"/>
               </a:rPr>
-              <a:t>Un slot por tipo</a:t>
+              <a:t>Tres fases</a:t>
             </a:r>
           </a:p>
         </p:txBody>
@@ -14770,8 +15037,8 @@
         </p:nvSpPr>
         <p:spPr>
           <a:xfrm>
-            <a:off x="8242369" y="3922776"/>
-            <a:ext cx="3382397" cy="713232"/>
+            <a:off x="8242369" y="3227832"/>
+            <a:ext cx="3382397" cy="512064"/>
           </a:xfrm>
           <a:prstGeom prst="rect">
             <a:avLst/>
@@ -14816,8 +15083,8 @@
         </p:nvSpPr>
         <p:spPr>
           <a:xfrm>
-            <a:off x="8370385" y="3977639"/>
-            <a:ext cx="3126365" cy="603504"/>
+            <a:off x="8370385" y="3282696"/>
+            <a:ext cx="3126365" cy="402336"/>
           </a:xfrm>
           <a:prstGeom prst="rect">
             <a:avLst/>
@@ -14836,60 +15103,53 @@
               </a:lnSpc>
             </a:pPr>
             <a:r>
-              <a:rPr sz="1200" b="0" i="0">
+              <a:rPr sz="1150" b="0" i="0">
                 <a:solidFill>
                   <a:srgbClr val="CBD5E1"/>
                 </a:solidFill>
                 <a:latin typeface="Segoe UI"/>
               </a:rPr>
-              <a:t>El estado inválido se elimina</a:t>
-            </a:r>
-          </a:p>
-        </p:txBody>
-      </p:sp>
-      <p:sp>
-        <p:nvSpPr>
-          <p:cNvPr id="30" name="Rectangle 29"/>
-          <p:cNvSpPr/>
-          <p:nvPr/>
-        </p:nvSpPr>
-        <p:spPr>
-          <a:xfrm>
-            <a:off x="566928" y="4636008"/>
-            <a:ext cx="3642582" cy="713232"/>
-          </a:xfrm>
-          <a:prstGeom prst="rect">
-            <a:avLst/>
-          </a:prstGeom>
-          <a:solidFill>
-            <a:srgbClr val="1E293B"/>
-          </a:solidFill>
-          <a:ln w="9525">
-            <a:solidFill>
-              <a:srgbClr val="334155"/>
-            </a:solidFill>
-          </a:ln>
-          <a:effectLst/>
-        </p:spPr>
-        <p:style>
-          <a:lnRef idx="1">
-            <a:schemeClr val="accent1"/>
-          </a:lnRef>
-          <a:fillRef idx="3">
-            <a:schemeClr val="accent1"/>
-          </a:fillRef>
-          <a:effectRef idx="2">
-            <a:schemeClr val="accent1"/>
-          </a:effectRef>
-          <a:fontRef idx="minor">
-            <a:schemeClr val="lt1"/>
-          </a:fontRef>
-        </p:style>
-        <p:txBody>
-          <a:bodyPr rtlCol="0" anchor="ctr"/>
-          <a:lstStyle/>
-          <a:p>
-            <a:pPr algn="ctr"/>
+              <a:t>Evitar explosión de combinaciones</a:t>
+            </a:r>
+          </a:p>
+        </p:txBody>
+      </p:sp>
+      <p:sp>
+        <p:nvSpPr>
+          <p:cNvPr id="30" name="TextBox 29"/>
+          <p:cNvSpPr txBox="1"/>
+          <p:nvPr/>
+        </p:nvSpPr>
+        <p:spPr>
+          <a:xfrm>
+            <a:off x="566928" y="3931920"/>
+            <a:ext cx="11057839" cy="237744"/>
+          </a:xfrm>
+          <a:prstGeom prst="rect">
+            <a:avLst/>
+          </a:prstGeom>
+          <a:noFill/>
+        </p:spPr>
+        <p:txBody>
+          <a:bodyPr wrap="square" anchor="t" lIns="0" rIns="0" tIns="0" bIns="0">
+            <a:spAutoFit/>
+          </a:bodyPr>
+          <a:lstStyle/>
+          <a:p>
+            <a:pPr algn="l">
+              <a:lnSpc>
+                <a:spcPct val="100000"/>
+              </a:lnSpc>
+            </a:pPr>
+            <a:r>
+              <a:rPr sz="1050" b="1" i="0">
+                <a:solidFill>
+                  <a:srgbClr val="4ADE80"/>
+                </a:solidFill>
+                <a:latin typeface="Segoe UI"/>
+              </a:rPr>
+              <a:t>QUÉ DESCUBRÍ AL IMPLEMENTAR</a:t>
+            </a:r>
           </a:p>
         </p:txBody>
       </p:sp>
@@ -14901,80 +15161,73 @@
         </p:nvSpPr>
         <p:spPr>
           <a:xfrm>
-            <a:off x="694944" y="4690872"/>
-            <a:ext cx="3386550" cy="603504"/>
-          </a:xfrm>
-          <a:prstGeom prst="rect">
-            <a:avLst/>
-          </a:prstGeom>
-          <a:noFill/>
-        </p:spPr>
-        <p:txBody>
-          <a:bodyPr wrap="square" anchor="ctr" lIns="0" rIns="0" tIns="0" bIns="0">
-            <a:spAutoFit/>
-          </a:bodyPr>
-          <a:lstStyle/>
-          <a:p>
-            <a:pPr>
-              <a:lnSpc>
-                <a:spcPct val="95000"/>
-              </a:lnSpc>
-            </a:pPr>
-            <a:r>
-              <a:rPr sz="1200" b="0" i="0">
-                <a:solidFill>
-                  <a:srgbClr val="CBD5E1"/>
-                </a:solidFill>
-                <a:latin typeface="Segoe UI"/>
-              </a:rPr>
-              <a:t>FSM con estados por acción</a:t>
-            </a:r>
-          </a:p>
-        </p:txBody>
-      </p:sp>
-      <p:sp>
-        <p:nvSpPr>
-          <p:cNvPr id="32" name="Rectangle 31"/>
-          <p:cNvSpPr/>
-          <p:nvPr/>
-        </p:nvSpPr>
-        <p:spPr>
-          <a:xfrm>
-            <a:off x="4209510" y="4636008"/>
-            <a:ext cx="4032859" cy="713232"/>
-          </a:xfrm>
-          <a:prstGeom prst="rect">
-            <a:avLst/>
-          </a:prstGeom>
-          <a:solidFill>
-            <a:srgbClr val="1E293B"/>
-          </a:solidFill>
-          <a:ln w="9525">
-            <a:solidFill>
-              <a:srgbClr val="334155"/>
-            </a:solidFill>
-          </a:ln>
-          <a:effectLst/>
-        </p:spPr>
-        <p:style>
-          <a:lnRef idx="1">
-            <a:schemeClr val="accent1"/>
-          </a:lnRef>
-          <a:fillRef idx="3">
-            <a:schemeClr val="accent1"/>
-          </a:fillRef>
-          <a:effectRef idx="2">
-            <a:schemeClr val="accent1"/>
-          </a:effectRef>
-          <a:fontRef idx="minor">
-            <a:schemeClr val="lt1"/>
-          </a:fontRef>
-        </p:style>
-        <p:txBody>
-          <a:bodyPr rtlCol="0" anchor="ctr"/>
-          <a:lstStyle/>
-          <a:p>
-            <a:pPr algn="ctr"/>
+            <a:off x="566928" y="4187952"/>
+            <a:ext cx="256032" cy="237744"/>
+          </a:xfrm>
+          <a:prstGeom prst="rect">
+            <a:avLst/>
+          </a:prstGeom>
+          <a:noFill/>
+        </p:spPr>
+        <p:txBody>
+          <a:bodyPr wrap="square" anchor="t" lIns="0" rIns="0" tIns="0" bIns="0">
+            <a:spAutoFit/>
+          </a:bodyPr>
+          <a:lstStyle/>
+          <a:p>
+            <a:pPr algn="l">
+              <a:lnSpc>
+                <a:spcPct val="100000"/>
+              </a:lnSpc>
+            </a:pPr>
+            <a:r>
+              <a:rPr sz="1200" b="1" i="0">
+                <a:solidFill>
+                  <a:srgbClr val="F87171"/>
+                </a:solidFill>
+                <a:latin typeface="Segoe UI"/>
+              </a:rPr>
+              <a:t>×</a:t>
+            </a:r>
+          </a:p>
+        </p:txBody>
+      </p:sp>
+      <p:sp>
+        <p:nvSpPr>
+          <p:cNvPr id="32" name="TextBox 31"/>
+          <p:cNvSpPr txBox="1"/>
+          <p:nvPr/>
+        </p:nvSpPr>
+        <p:spPr>
+          <a:xfrm>
+            <a:off x="841247" y="4187952"/>
+            <a:ext cx="10692079" cy="219456"/>
+          </a:xfrm>
+          <a:prstGeom prst="rect">
+            <a:avLst/>
+          </a:prstGeom>
+          <a:noFill/>
+        </p:spPr>
+        <p:txBody>
+          <a:bodyPr wrap="square" anchor="t" lIns="0" rIns="0" tIns="0" bIns="0">
+            <a:spAutoFit/>
+          </a:bodyPr>
+          <a:lstStyle/>
+          <a:p>
+            <a:pPr algn="l">
+              <a:lnSpc>
+                <a:spcPct val="100000"/>
+              </a:lnSpc>
+            </a:pPr>
+            <a:r>
+              <a:rPr sz="1150" b="1" i="0">
+                <a:solidFill>
+                  <a:srgbClr val="F8FAFC"/>
+                </a:solidFill>
+                <a:latin typeface="Segoe UI"/>
+              </a:rPr>
+              <a:t>Un FBX mal centrado parecía un bug de arquitectura</a:t>
+            </a:r>
           </a:p>
         </p:txBody>
       </p:sp>
@@ -14986,80 +15239,73 @@
         </p:nvSpPr>
         <p:spPr>
           <a:xfrm>
-            <a:off x="4337526" y="4690872"/>
-            <a:ext cx="3776827" cy="603504"/>
-          </a:xfrm>
-          <a:prstGeom prst="rect">
-            <a:avLst/>
-          </a:prstGeom>
-          <a:noFill/>
-        </p:spPr>
-        <p:txBody>
-          <a:bodyPr wrap="square" anchor="ctr" lIns="0" rIns="0" tIns="0" bIns="0">
-            <a:spAutoFit/>
-          </a:bodyPr>
-          <a:lstStyle/>
-          <a:p>
-            <a:pPr>
-              <a:lnSpc>
-                <a:spcPct val="95000"/>
-              </a:lnSpc>
-            </a:pPr>
-            <a:r>
-              <a:rPr sz="1200" b="0" i="0">
-                <a:solidFill>
-                  <a:srgbClr val="CBD5E1"/>
-                </a:solidFill>
-                <a:latin typeface="Segoe UI"/>
-              </a:rPr>
-              <a:t>Tres fases</a:t>
-            </a:r>
-          </a:p>
-        </p:txBody>
-      </p:sp>
-      <p:sp>
-        <p:nvSpPr>
-          <p:cNvPr id="34" name="Rectangle 33"/>
-          <p:cNvSpPr/>
-          <p:nvPr/>
-        </p:nvSpPr>
-        <p:spPr>
-          <a:xfrm>
-            <a:off x="8242369" y="4636008"/>
-            <a:ext cx="3382397" cy="713232"/>
-          </a:xfrm>
-          <a:prstGeom prst="rect">
-            <a:avLst/>
-          </a:prstGeom>
-          <a:solidFill>
-            <a:srgbClr val="1E293B"/>
-          </a:solidFill>
-          <a:ln w="9525">
-            <a:solidFill>
-              <a:srgbClr val="334155"/>
-            </a:solidFill>
-          </a:ln>
-          <a:effectLst/>
-        </p:spPr>
-        <p:style>
-          <a:lnRef idx="1">
-            <a:schemeClr val="accent1"/>
-          </a:lnRef>
-          <a:fillRef idx="3">
-            <a:schemeClr val="accent1"/>
-          </a:fillRef>
-          <a:effectRef idx="2">
-            <a:schemeClr val="accent1"/>
-          </a:effectRef>
-          <a:fontRef idx="minor">
-            <a:schemeClr val="lt1"/>
-          </a:fontRef>
-        </p:style>
-        <p:txBody>
-          <a:bodyPr rtlCol="0" anchor="ctr"/>
-          <a:lstStyle/>
-          <a:p>
-            <a:pPr algn="ctr"/>
+            <a:off x="841247" y="4379976"/>
+            <a:ext cx="10692079" cy="201168"/>
+          </a:xfrm>
+          <a:prstGeom prst="rect">
+            <a:avLst/>
+          </a:prstGeom>
+          <a:noFill/>
+        </p:spPr>
+        <p:txBody>
+          <a:bodyPr wrap="square" anchor="t" lIns="0" rIns="0" tIns="0" bIns="0">
+            <a:spAutoFit/>
+          </a:bodyPr>
+          <a:lstStyle/>
+          <a:p>
+            <a:pPr algn="l">
+              <a:lnSpc>
+                <a:spcPct val="100000"/>
+              </a:lnSpc>
+            </a:pPr>
+            <a:r>
+              <a:rPr sz="950" b="0" i="0">
+                <a:solidFill>
+                  <a:srgbClr val="94A3B8"/>
+                </a:solidFill>
+                <a:latin typeface="Segoe UI"/>
+              </a:rPr>
+              <a:t>la nave se dibujaba al lado de su anillo; era el pivote del export, no el código</a:t>
+            </a:r>
+          </a:p>
+        </p:txBody>
+      </p:sp>
+      <p:sp>
+        <p:nvSpPr>
+          <p:cNvPr id="34" name="TextBox 33"/>
+          <p:cNvSpPr txBox="1"/>
+          <p:nvPr/>
+        </p:nvSpPr>
+        <p:spPr>
+          <a:xfrm>
+            <a:off x="566928" y="4599432"/>
+            <a:ext cx="256032" cy="237744"/>
+          </a:xfrm>
+          <a:prstGeom prst="rect">
+            <a:avLst/>
+          </a:prstGeom>
+          <a:noFill/>
+        </p:spPr>
+        <p:txBody>
+          <a:bodyPr wrap="square" anchor="t" lIns="0" rIns="0" tIns="0" bIns="0">
+            <a:spAutoFit/>
+          </a:bodyPr>
+          <a:lstStyle/>
+          <a:p>
+            <a:pPr algn="l">
+              <a:lnSpc>
+                <a:spcPct val="100000"/>
+              </a:lnSpc>
+            </a:pPr>
+            <a:r>
+              <a:rPr sz="1200" b="1" i="0">
+                <a:solidFill>
+                  <a:srgbClr val="F87171"/>
+                </a:solidFill>
+                <a:latin typeface="Segoe UI"/>
+              </a:rPr>
+              <a:t>×</a:t>
+            </a:r>
           </a:p>
         </p:txBody>
       </p:sp>
@@ -15071,40 +15317,313 @@
         </p:nvSpPr>
         <p:spPr>
           <a:xfrm>
-            <a:off x="8370385" y="4690872"/>
-            <a:ext cx="3126365" cy="603504"/>
-          </a:xfrm>
-          <a:prstGeom prst="rect">
-            <a:avLst/>
-          </a:prstGeom>
-          <a:noFill/>
-        </p:spPr>
-        <p:txBody>
-          <a:bodyPr wrap="square" anchor="ctr" lIns="0" rIns="0" tIns="0" bIns="0">
-            <a:spAutoFit/>
-          </a:bodyPr>
-          <a:lstStyle/>
-          <a:p>
-            <a:pPr>
-              <a:lnSpc>
-                <a:spcPct val="95000"/>
-              </a:lnSpc>
-            </a:pPr>
-            <a:r>
-              <a:rPr sz="1200" b="0" i="0">
-                <a:solidFill>
-                  <a:srgbClr val="CBD5E1"/>
-                </a:solidFill>
-                <a:latin typeface="Segoe UI"/>
-              </a:rPr>
-              <a:t>Evitar explosión de combinaciones</a:t>
-            </a:r>
-          </a:p>
-        </p:txBody>
-      </p:sp>
-      <p:sp>
-        <p:nvSpPr>
-          <p:cNvPr id="36" name="Rounded Rectangle 35"/>
+            <a:off x="841247" y="4599432"/>
+            <a:ext cx="10692079" cy="219456"/>
+          </a:xfrm>
+          <a:prstGeom prst="rect">
+            <a:avLst/>
+          </a:prstGeom>
+          <a:noFill/>
+        </p:spPr>
+        <p:txBody>
+          <a:bodyPr wrap="square" anchor="t" lIns="0" rIns="0" tIns="0" bIns="0">
+            <a:spAutoFit/>
+          </a:bodyPr>
+          <a:lstStyle/>
+          <a:p>
+            <a:pPr algn="l">
+              <a:lnSpc>
+                <a:spcPct val="100000"/>
+              </a:lnSpc>
+            </a:pPr>
+            <a:r>
+              <a:rPr sz="1150" b="1" i="0">
+                <a:solidFill>
+                  <a:srgbClr val="F8FAFC"/>
+                </a:solidFill>
+                <a:latin typeface="Segoe UI"/>
+              </a:rPr>
+              <a:t>transform.Find por ruta cortó el panel con un NullReference</a:t>
+            </a:r>
+          </a:p>
+        </p:txBody>
+      </p:sp>
+      <p:sp>
+        <p:nvSpPr>
+          <p:cNvPr id="36" name="TextBox 35"/>
+          <p:cNvSpPr txBox="1"/>
+          <p:nvPr/>
+        </p:nvSpPr>
+        <p:spPr>
+          <a:xfrm>
+            <a:off x="841247" y="4791456"/>
+            <a:ext cx="10692079" cy="201168"/>
+          </a:xfrm>
+          <a:prstGeom prst="rect">
+            <a:avLst/>
+          </a:prstGeom>
+          <a:noFill/>
+        </p:spPr>
+        <p:txBody>
+          <a:bodyPr wrap="square" anchor="t" lIns="0" rIns="0" tIns="0" bIns="0">
+            <a:spAutoFit/>
+          </a:bodyPr>
+          <a:lstStyle/>
+          <a:p>
+            <a:pPr algn="l">
+              <a:lnSpc>
+                <a:spcPct val="100000"/>
+              </a:lnSpc>
+            </a:pPr>
+            <a:r>
+              <a:rPr sz="950" b="0" i="0">
+                <a:solidFill>
+                  <a:srgbClr val="94A3B8"/>
+                </a:solidFill>
+                <a:latin typeface="Segoe UI"/>
+              </a:rPr>
+              <a:t>la vista no debe buscar referencias: la fábrica devuelve tipos</a:t>
+            </a:r>
+          </a:p>
+        </p:txBody>
+      </p:sp>
+      <p:sp>
+        <p:nvSpPr>
+          <p:cNvPr id="37" name="TextBox 36"/>
+          <p:cNvSpPr txBox="1"/>
+          <p:nvPr/>
+        </p:nvSpPr>
+        <p:spPr>
+          <a:xfrm>
+            <a:off x="566928" y="5010912"/>
+            <a:ext cx="256032" cy="237744"/>
+          </a:xfrm>
+          <a:prstGeom prst="rect">
+            <a:avLst/>
+          </a:prstGeom>
+          <a:noFill/>
+        </p:spPr>
+        <p:txBody>
+          <a:bodyPr wrap="square" anchor="t" lIns="0" rIns="0" tIns="0" bIns="0">
+            <a:spAutoFit/>
+          </a:bodyPr>
+          <a:lstStyle/>
+          <a:p>
+            <a:pPr algn="l">
+              <a:lnSpc>
+                <a:spcPct val="100000"/>
+              </a:lnSpc>
+            </a:pPr>
+            <a:r>
+              <a:rPr sz="1200" b="1" i="0">
+                <a:solidFill>
+                  <a:srgbClr val="F87171"/>
+                </a:solidFill>
+                <a:latin typeface="Segoe UI"/>
+              </a:rPr>
+              <a:t>×</a:t>
+            </a:r>
+          </a:p>
+        </p:txBody>
+      </p:sp>
+      <p:sp>
+        <p:nvSpPr>
+          <p:cNvPr id="38" name="TextBox 37"/>
+          <p:cNvSpPr txBox="1"/>
+          <p:nvPr/>
+        </p:nvSpPr>
+        <p:spPr>
+          <a:xfrm>
+            <a:off x="841247" y="5010912"/>
+            <a:ext cx="10692079" cy="219456"/>
+          </a:xfrm>
+          <a:prstGeom prst="rect">
+            <a:avLst/>
+          </a:prstGeom>
+          <a:noFill/>
+        </p:spPr>
+        <p:txBody>
+          <a:bodyPr wrap="square" anchor="t" lIns="0" rIns="0" tIns="0" bIns="0">
+            <a:spAutoFit/>
+          </a:bodyPr>
+          <a:lstStyle/>
+          <a:p>
+            <a:pPr algn="l">
+              <a:lnSpc>
+                <a:spcPct val="100000"/>
+              </a:lnSpc>
+            </a:pPr>
+            <a:r>
+              <a:rPr sz="1150" b="1" i="0">
+                <a:solidFill>
+                  <a:srgbClr val="F8FAFC"/>
+                </a:solidFill>
+                <a:latin typeface="Segoe UI"/>
+              </a:rPr>
+              <a:t>[Inject] llegaba después de Start</a:t>
+            </a:r>
+          </a:p>
+        </p:txBody>
+      </p:sp>
+      <p:sp>
+        <p:nvSpPr>
+          <p:cNvPr id="39" name="TextBox 38"/>
+          <p:cNvSpPr txBox="1"/>
+          <p:nvPr/>
+        </p:nvSpPr>
+        <p:spPr>
+          <a:xfrm>
+            <a:off x="841247" y="5202936"/>
+            <a:ext cx="10692079" cy="201168"/>
+          </a:xfrm>
+          <a:prstGeom prst="rect">
+            <a:avLst/>
+          </a:prstGeom>
+          <a:noFill/>
+        </p:spPr>
+        <p:txBody>
+          <a:bodyPr wrap="square" anchor="t" lIns="0" rIns="0" tIns="0" bIns="0">
+            <a:spAutoFit/>
+          </a:bodyPr>
+          <a:lstStyle/>
+          <a:p>
+            <a:pPr algn="l">
+              <a:lnSpc>
+                <a:spcPct val="100000"/>
+              </a:lnSpc>
+            </a:pPr>
+            <a:r>
+              <a:rPr sz="950" b="0" i="0">
+                <a:solidFill>
+                  <a:srgbClr val="94A3B8"/>
+                </a:solidFill>
+                <a:latin typeface="Segoe UI"/>
+              </a:rPr>
+              <a:t>la nave 3D nunca se construía; se resuelve con un evento Ready, no con un orden implícito</a:t>
+            </a:r>
+          </a:p>
+        </p:txBody>
+      </p:sp>
+      <p:sp>
+        <p:nvSpPr>
+          <p:cNvPr id="40" name="TextBox 39"/>
+          <p:cNvSpPr txBox="1"/>
+          <p:nvPr/>
+        </p:nvSpPr>
+        <p:spPr>
+          <a:xfrm>
+            <a:off x="566928" y="5422392"/>
+            <a:ext cx="256032" cy="237744"/>
+          </a:xfrm>
+          <a:prstGeom prst="rect">
+            <a:avLst/>
+          </a:prstGeom>
+          <a:noFill/>
+        </p:spPr>
+        <p:txBody>
+          <a:bodyPr wrap="square" anchor="t" lIns="0" rIns="0" tIns="0" bIns="0">
+            <a:spAutoFit/>
+          </a:bodyPr>
+          <a:lstStyle/>
+          <a:p>
+            <a:pPr algn="l">
+              <a:lnSpc>
+                <a:spcPct val="100000"/>
+              </a:lnSpc>
+            </a:pPr>
+            <a:r>
+              <a:rPr sz="1200" b="1" i="0">
+                <a:solidFill>
+                  <a:srgbClr val="F87171"/>
+                </a:solidFill>
+                <a:latin typeface="Segoe UI"/>
+              </a:rPr>
+              <a:t>×</a:t>
+            </a:r>
+          </a:p>
+        </p:txBody>
+      </p:sp>
+      <p:sp>
+        <p:nvSpPr>
+          <p:cNvPr id="41" name="TextBox 40"/>
+          <p:cNvSpPr txBox="1"/>
+          <p:nvPr/>
+        </p:nvSpPr>
+        <p:spPr>
+          <a:xfrm>
+            <a:off x="841247" y="5422392"/>
+            <a:ext cx="10692079" cy="219456"/>
+          </a:xfrm>
+          <a:prstGeom prst="rect">
+            <a:avLst/>
+          </a:prstGeom>
+          <a:noFill/>
+        </p:spPr>
+        <p:txBody>
+          <a:bodyPr wrap="square" anchor="t" lIns="0" rIns="0" tIns="0" bIns="0">
+            <a:spAutoFit/>
+          </a:bodyPr>
+          <a:lstStyle/>
+          <a:p>
+            <a:pPr algn="l">
+              <a:lnSpc>
+                <a:spcPct val="100000"/>
+              </a:lnSpc>
+            </a:pPr>
+            <a:r>
+              <a:rPr sz="1150" b="1" i="0">
+                <a:solidFill>
+                  <a:srgbClr val="F8FAFC"/>
+                </a:solidFill>
+                <a:latin typeface="Segoe UI"/>
+              </a:rPr>
+              <a:t>El EventSystem del template no respondía</a:t>
+            </a:r>
+          </a:p>
+        </p:txBody>
+      </p:sp>
+      <p:sp>
+        <p:nvSpPr>
+          <p:cNvPr id="42" name="TextBox 41"/>
+          <p:cNvSpPr txBox="1"/>
+          <p:nvPr/>
+        </p:nvSpPr>
+        <p:spPr>
+          <a:xfrm>
+            <a:off x="841247" y="5614416"/>
+            <a:ext cx="10692079" cy="201168"/>
+          </a:xfrm>
+          <a:prstGeom prst="rect">
+            <a:avLst/>
+          </a:prstGeom>
+          <a:noFill/>
+        </p:spPr>
+        <p:txBody>
+          <a:bodyPr wrap="square" anchor="t" lIns="0" rIns="0" tIns="0" bIns="0">
+            <a:spAutoFit/>
+          </a:bodyPr>
+          <a:lstStyle/>
+          <a:p>
+            <a:pPr algn="l">
+              <a:lnSpc>
+                <a:spcPct val="100000"/>
+              </a:lnSpc>
+            </a:pPr>
+            <a:r>
+              <a:rPr sz="950" b="0" i="0">
+                <a:solidFill>
+                  <a:srgbClr val="94A3B8"/>
+                </a:solidFill>
+                <a:latin typeface="Segoe UI"/>
+              </a:rPr>
+              <a:t>con el Input System nuevo, StandaloneInputModule es inerte: hace falta InputSystemUIInputModule</a:t>
+            </a:r>
+          </a:p>
+        </p:txBody>
+      </p:sp>
+      <p:sp>
+        <p:nvSpPr>
+          <p:cNvPr id="43" name="Rounded Rectangle 42"/>
           <p:cNvSpPr/>
           <p:nvPr/>
         </p:nvSpPr>
@@ -15148,7 +15667,7 @@
       </p:sp>
       <p:sp>
         <p:nvSpPr>
-          <p:cNvPr id="37" name="Rounded Rectangle 36"/>
+          <p:cNvPr id="44" name="Rounded Rectangle 43"/>
           <p:cNvSpPr/>
           <p:nvPr/>
         </p:nvSpPr>
@@ -15192,7 +15711,7 @@
       </p:sp>
       <p:sp>
         <p:nvSpPr>
-          <p:cNvPr id="38" name="TextBox 37"/>
+          <p:cNvPr id="45" name="TextBox 44"/>
           <p:cNvSpPr txBox="1"/>
           <p:nvPr/>
         </p:nvSpPr>
@@ -15224,7 +15743,7 @@
                 </a:solidFill>
                 <a:latin typeface="Segoe UI"/>
               </a:rPr>
-              <a:t>Ningún cambio altera qué resuelve cada prototipo: cambian cómo se respeta la regla de dependencia.</a:t>
+              <a:t>Los cuatro cambios del TP1 están en docs/01 §5; estos cuatro hallazgos, en el código.</a:t>
             </a:r>
           </a:p>
         </p:txBody>
@@ -18235,7 +18754,7 @@
                 </a:solidFill>
                 <a:latin typeface="Segoe UI"/>
               </a:rPr>
-              <a:t>Cada prototipo: carpeta independiente · una escena · su propia suite · dominio sin UnityEngine.</a:t>
+              <a:t>Una escena real por prototipo, con modelos 3D (Kenney CC0) y UI nativa: se puede jugar la prueba.</a:t>
             </a:r>
           </a:p>
         </p:txBody>
@@ -19593,7 +20112,7 @@
                 </a:solidFill>
                 <a:latin typeface="Segoe UI"/>
               </a:rPr>
-              <a:t>Cómo se reproduce todo en 4 comandos</a:t>
+              <a:t>Cómo se reproduce y se verifica, sin abrir el editor</a:t>
             </a:r>
           </a:p>
         </p:txBody>
@@ -19653,7 +20172,7 @@
         <p:spPr>
           <a:xfrm>
             <a:off x="566928" y="1783080"/>
-            <a:ext cx="11057839" cy="2551176"/>
+            <a:ext cx="11057839" cy="3072384"/>
           </a:xfrm>
           <a:prstGeom prst="roundRect">
             <a:avLst>
@@ -19699,7 +20218,7 @@
         <p:spPr>
           <a:xfrm>
             <a:off x="786384" y="1984248"/>
-            <a:ext cx="10618927" cy="2112264"/>
+            <a:ext cx="10618927" cy="2633472"/>
           </a:xfrm>
           <a:prstGeom prst="rect">
             <a:avLst/>
@@ -19718,13 +20237,29 @@
               </a:lnSpc>
             </a:pPr>
             <a:r>
-              <a:rPr sz="1200" b="0" i="0">
+              <a:rPr sz="1150" b="0" i="0">
+                <a:solidFill>
+                  <a:srgbClr val="94A3B8"/>
+                </a:solidFill>
+                <a:latin typeface="Consolas"/>
+              </a:rPr>
+              <a:t># Escenas: se generan solas si faltan ([InitializeOnLoad]) o por menú</a:t>
+            </a:r>
+          </a:p>
+          <a:p>
+            <a:pPr>
+              <a:lnSpc>
+                <a:spcPct val="100000"/>
+              </a:lnSpc>
+            </a:pPr>
+            <a:r>
+              <a:rPr sz="1150" b="0" i="0">
                 <a:solidFill>
                   <a:srgbClr val="4ADE80"/>
                 </a:solidFill>
                 <a:latin typeface="Consolas"/>
               </a:rPr>
-              <a:t>$unity = "C:\Program Files\Unity\Hub\Editor\6000.5.9f1\Editor\Unity.exe"</a:t>
+              <a:t>unity command --project-path . menu --path "VoidHex/Build Prototype Scenes"</a:t>
             </a:r>
           </a:p>
           <a:p>
@@ -19734,7 +20269,7 @@
               </a:lnSpc>
             </a:pPr>
             <a:r>
-              <a:rPr sz="1200" b="0" i="0">
+              <a:rPr sz="1150" b="0" i="0">
                 <a:solidFill>
                   <a:srgbClr val="4ADE80"/>
                 </a:solidFill>
@@ -19750,13 +20285,29 @@
               </a:lnSpc>
             </a:pPr>
             <a:r>
-              <a:rPr sz="1200" b="0" i="0">
+              <a:rPr sz="1150" b="0" i="0">
+                <a:solidFill>
+                  <a:srgbClr val="94A3B8"/>
+                </a:solidFill>
+                <a:latin typeface="Consolas"/>
+              </a:rPr>
+              <a:t># Suite completa contra el editor en ejecución</a:t>
+            </a:r>
+          </a:p>
+          <a:p>
+            <a:pPr>
+              <a:lnSpc>
+                <a:spcPct val="100000"/>
+              </a:lnSpc>
+            </a:pPr>
+            <a:r>
+              <a:rPr sz="1150" b="0" i="0">
                 <a:solidFill>
                   <a:srgbClr val="4ADE80"/>
                 </a:solidFill>
                 <a:latin typeface="Consolas"/>
               </a:rPr>
-              <a:t>&amp; $unity -batchmode -nographics -projectPath . -runTests `</a:t>
+              <a:t>unity command --project-path . run_tests --mode EditMode</a:t>
             </a:r>
           </a:p>
           <a:p>
@@ -19766,13 +20317,13 @@
               </a:lnSpc>
             </a:pPr>
             <a:r>
-              <a:rPr sz="1200" b="0" i="0">
+              <a:rPr sz="1150" b="0" i="0">
                 <a:solidFill>
                   <a:srgbClr val="4ADE80"/>
                 </a:solidFill>
                 <a:latin typeface="Consolas"/>
               </a:rPr>
-              <a:t>    -testPlatform EditMode -testResults Logs/editmode-results.xml -quit</a:t>
+              <a:t>unity command --project-path . run_tests --mode PlayMode --async_tests</a:t>
             </a:r>
           </a:p>
           <a:p>
@@ -19782,7 +20333,7 @@
               </a:lnSpc>
             </a:pPr>
             <a:r>
-              <a:rPr sz="1200" b="0" i="0">
+              <a:rPr sz="1150" b="0" i="0">
                 <a:solidFill>
                   <a:srgbClr val="4ADE80"/>
                 </a:solidFill>
@@ -19798,29 +20349,29 @@
               </a:lnSpc>
             </a:pPr>
             <a:r>
-              <a:rPr sz="1200" b="0" i="0">
+              <a:rPr sz="1150" b="0" i="0">
+                <a:solidFill>
+                  <a:srgbClr val="94A3B8"/>
+                </a:solidFill>
+                <a:latin typeface="Consolas"/>
+              </a:rPr>
+              <a:t># Evidencia visual de las tres escenas</a:t>
+            </a:r>
+          </a:p>
+          <a:p>
+            <a:pPr>
+              <a:lnSpc>
+                <a:spcPct val="100000"/>
+              </a:lnSpc>
+            </a:pPr>
+            <a:r>
+              <a:rPr sz="1150" b="0" i="0">
                 <a:solidFill>
                   <a:srgbClr val="4ADE80"/>
                 </a:solidFill>
                 <a:latin typeface="Consolas"/>
               </a:rPr>
-              <a:t>&amp; $unity -batchmode -nographics -projectPath . -runTests `</a:t>
-            </a:r>
-          </a:p>
-          <a:p>
-            <a:pPr>
-              <a:lnSpc>
-                <a:spcPct val="100000"/>
-              </a:lnSpc>
-            </a:pPr>
-            <a:r>
-              <a:rPr sz="1200" b="0" i="0">
-                <a:solidFill>
-                  <a:srgbClr val="4ADE80"/>
-                </a:solidFill>
-                <a:latin typeface="Consolas"/>
-              </a:rPr>
-              <a:t>    -testPlatform PlayMode -testResults Logs/playmode-results.xml -quit</a:t>
+              <a:t>unity command --project-path . capture_game_view --source screen --save_path captura.png</a:t>
             </a:r>
           </a:p>
         </p:txBody>
@@ -19833,8 +20384,8 @@
         </p:nvSpPr>
         <p:spPr>
           <a:xfrm>
-            <a:off x="566928" y="4526280"/>
-            <a:ext cx="11057839" cy="914400"/>
+            <a:off x="566928" y="4617720"/>
+            <a:ext cx="11057839" cy="777240"/>
           </a:xfrm>
           <a:prstGeom prst="rect">
             <a:avLst/>
@@ -19849,17 +20400,17 @@
           <a:p>
             <a:pPr algn="l">
               <a:lnSpc>
-                <a:spcPct val="100000"/>
-              </a:lnSpc>
-            </a:pPr>
-            <a:r>
-              <a:rPr sz="1400" b="0" i="0">
+                <a:spcPct val="115000"/>
+              </a:lnSpc>
+            </a:pPr>
+            <a:r>
+              <a:rPr sz="1300" b="0" i="0">
                 <a:solidFill>
                   <a:srgbClr val="CBD5E1"/>
                 </a:solidFill>
                 <a:latin typeface="Segoe UI"/>
               </a:rPr>
-              <a:t>En el editor:  VoidHex → Build Prototype Scenes   ·   Window → General → Test Runner</a:t>
+              <a:t>Tres verificadores propios: referencias de asmdef, integridad de escenas y auditoría de la lógica pura sin Unity.</a:t>
             </a:r>
           </a:p>
         </p:txBody>
@@ -19986,7 +20537,7 @@
                 </a:solidFill>
                 <a:latin typeface="Segoe UI"/>
               </a:rPr>
-              <a:t>Sin pasos manuales: la suite pasa en un proyecto recién clonado.</a:t>
+              <a:t>Unity 6000.5.9f1 trae el paquete com.unity.pipeline: el editor se controla por CLI.</a:t>
             </a:r>
           </a:p>
         </p:txBody>
@@ -23331,7 +23882,7 @@
                 </a:solidFill>
                 <a:latin typeface="Segoe UI"/>
               </a:rPr>
-              <a:t>cuando la celda cambia</a:t>
+              <a:t>por cada mutación real</a:t>
             </a:r>
           </a:p>
         </p:txBody>
@@ -23494,7 +24045,7 @@
                 </a:solidFill>
                 <a:latin typeface="Segoe UI"/>
               </a:rPr>
-              <a:t>si se escribe el mismo valor</a:t>
+              <a:t>al reescribir el mismo valor</a:t>
             </a:r>
           </a:p>
         </p:txBody>
@@ -23579,7 +24130,7 @@
                 </a:solidFill>
                 <a:latin typeface="Segoe UI"/>
               </a:rPr>
-              <a:t>—</a:t>
+              <a:t>4</a:t>
             </a:r>
           </a:p>
         </p:txBody>
@@ -23618,7 +24169,7 @@
                 </a:solidFill>
                 <a:latin typeface="Segoe UI"/>
               </a:rPr>
-              <a:t>Update()</a:t>
+              <a:t>redibujos</a:t>
             </a:r>
           </a:p>
         </p:txBody>
@@ -23657,7 +24208,7 @@
                 </a:solidFill>
                 <a:latin typeface="Segoe UI"/>
               </a:rPr>
-              <a:t>el presentador no tiene</a:t>
+              <a:t>en un mapa 12×12 con 4 obstáculos</a:t>
             </a:r>
           </a:p>
         </p:txBody>

</xml_diff>

<commit_message>
Fix stale test counts in the deck and presentation notes
docs/07 and the generated .pptx still said 22 tests (21 Edit + 1 Play). The suite
actually has 81: P1 5, P2 7, P3 9 and 59 for the playable loop, plus 1 PlayMode.

The deck is part of the deliverable, so a number that contradicts the README and
the Test Runner is a credibility risk in the oral defense.

Deck regenerated and verified: 21 slides, 0 layout problems.
</commit_message>
<xml_diff>
--- a/docs/presentacion/TP2-VoidHex-Tactics.pptx
+++ b/docs/presentacion/TP2-VoidHex-Tactics.pptx
@@ -1013,12 +1013,12 @@
           <a:lstStyle/>
           <a:p>
             <a:r>
-              <a:t>50 s. 21 en Edit Mode y 1 en Play Mode: 22, corridos y verdes dos veces (antes y después</a:t>
-            </a:r>
-          </a:p>
-          <a:p>
-            <a:r>
-              <a:t> del rediseño de UI y de los assets).</a:t>
+              <a:t>50 s. 80 en Edit Mode y 1 en Play Mode: 81, corridos y verdes dos veces (antes y después</a:t>
+            </a:r>
+          </a:p>
+          <a:p>
+            <a:r>
+              <a:t> del rediseño de UI y de los assets). Reparto: P1 5, P2 7, P3 9 y 59 del bucle jugable.</a:t>
             </a:r>
           </a:p>
           <a:p/>
@@ -5759,7 +5759,7 @@
                 </a:solidFill>
                 <a:latin typeface="Segoe UI"/>
               </a:rPr>
-              <a:t>Matias Andres Fahler   ·   Unity 6000.5.9f1   ·   tag tp2   ·   22 tests verdes</a:t>
+              <a:t>Matias Andres Fahler   ·   Unity 6000.5.9f1   ·   tag tp2   ·   81 tests verdes</a:t>
             </a:r>
           </a:p>
         </p:txBody>
@@ -11935,7 +11935,7 @@
                 </a:solidFill>
                 <a:latin typeface="Segoe UI"/>
               </a:rPr>
-              <a:t>21 tests en Edit Mode  ·  1 en Play Mode  ·  el único Play Mode es P2, porque es el único donde importa que Unity invoque al adaptador.</a:t>
+              <a:t>80 tests en Edit Mode (P1 5 · P2 7 · P3 9 · bucle 59)  ·  1 en Play Mode  ·  el único Play Mode es P2, porque es el único donde importa que Unity invoque al adaptador.</a:t>
             </a:r>
           </a:p>
         </p:txBody>
@@ -16255,7 +16255,7 @@
                 </a:solidFill>
                 <a:latin typeface="Segoe UI"/>
               </a:rPr>
-              <a:t>22 tests verdes · tag tp2</a:t>
+              <a:t>81 tests verdes · tag tp2</a:t>
             </a:r>
           </a:p>
         </p:txBody>

</xml_diff>